<commit_message>
Presentation: reconcile executive deck to v2.3 five-geography region model
- Slide 6 (placement): five geographies with distribution model (US 3-region;
  Europe/Australia/Asia Pacific/Middle East 2-region); Standard set corrected
  (Switzerland North not Belgium; East Asia/Southeast Asia/Australia now Standard);
  Restricted = East US 2 + North/West Europe; Japan East pending note
- Slide 7 (Middle East): retitled 'DR Not Offered (Legal Pending)'; DR_NOT_OFFERED
  per DEC-001 with no DR region assigned; Switzerland North cross-geo path staged
  but INACTIVE (removed active Belgium Central DR claim)
- Regenerated .pptx (PDF export intentionally skipped per current instruction)
</commit_message>
<xml_diff>
--- a/docs/presentation/acrme_executive_presentation.pptx
+++ b/docs/presentation/acrme_executive_presentation.pptx
@@ -13305,7 +13305,7 @@
                 </a:solidFill>
                 <a:latin typeface="Calibri"/>
               </a:rPr>
-              <a:t>Managed regions are split into two classes. Hard rules filter candidates first; the engine then scores the survivors on five weighted components.</a:t>
+              <a:t>Managed regions span five geographies — US is three-region; Europe, Australia, Asia Pacific and Middle East are two-region. They split into two classes: hard rules filter candidates first, then the engine scores the survivors on five weighted components. Japan East is pending confirmation.</a:t>
             </a:r>
           </a:p>
         </p:txBody>
@@ -13451,7 +13451,7 @@
                 </a:solidFill>
                 <a:latin typeface="Calibri"/>
               </a:rPr>
-              <a:t>North America:  </a:t>
+              <a:t>US (3-region):  </a:t>
             </a:r>
             <a:r>
               <a:rPr sz="1250" b="0" i="0">
@@ -13476,7 +13476,7 @@
                 </a:solidFill>
                 <a:latin typeface="Calibri"/>
               </a:rPr>
-              <a:t>Europe:  </a:t>
+              <a:t>Europe (2-region):  </a:t>
             </a:r>
             <a:r>
               <a:rPr sz="1250" b="0" i="0">
@@ -13485,7 +13485,7 @@
                 </a:solidFill>
                 <a:latin typeface="Calibri"/>
               </a:rPr>
-              <a:t>Sweden Central, Belgium Central</a:t>
+              <a:t>Switzerland North, Sweden Central</a:t>
             </a:r>
           </a:p>
           <a:p>
@@ -13501,7 +13501,7 @@
                 </a:solidFill>
                 <a:latin typeface="Calibri"/>
               </a:rPr>
-              <a:t>Middle East:  </a:t>
+              <a:t>Australia (2-region):  </a:t>
             </a:r>
             <a:r>
               <a:rPr sz="1250" b="0" i="0">
@@ -13510,7 +13510,7 @@
                 </a:solidFill>
                 <a:latin typeface="Calibri"/>
               </a:rPr>
-              <a:t>Saudi Arabia, UAE North</a:t>
+              <a:t>Australia East, Australia Southeast</a:t>
             </a:r>
           </a:p>
           <a:p>
@@ -13526,7 +13526,7 @@
                 </a:solidFill>
                 <a:latin typeface="Calibri"/>
               </a:rPr>
-              <a:t>Asia Pacific:  </a:t>
+              <a:t>Asia Pacific (2-region):  </a:t>
             </a:r>
             <a:r>
               <a:rPr sz="1250" b="0" i="0">
@@ -13535,7 +13535,32 @@
                 </a:solidFill>
                 <a:latin typeface="Calibri"/>
               </a:rPr>
-              <a:t>Japan East, Southeast Asia, Australia East</a:t>
+              <a:t>East Asia, Southeast Asia</a:t>
+            </a:r>
+          </a:p>
+          <a:p>
+            <a:pPr>
+              <a:spcAft>
+                <a:spcPts val="400"/>
+              </a:spcAft>
+            </a:pPr>
+            <a:r>
+              <a:rPr sz="1250" b="1" i="0">
+                <a:solidFill>
+                  <a:srgbClr val="0B2E4F"/>
+                </a:solidFill>
+                <a:latin typeface="Calibri"/>
+              </a:rPr>
+              <a:t>Middle East (2-region):  </a:t>
+            </a:r>
+            <a:r>
+              <a:rPr sz="1250" b="0" i="0">
+                <a:solidFill>
+                  <a:srgbClr val="1F2A37"/>
+                </a:solidFill>
+                <a:latin typeface="Calibri"/>
+              </a:rPr>
+              <a:t>Saudi Arabia Central, UAE North</a:t>
             </a:r>
           </a:p>
         </p:txBody>
@@ -13703,7 +13728,7 @@
                 </a:solidFill>
                 <a:latin typeface="Calibri"/>
               </a:rPr>
-              <a:t>•  East US 2 (North America)</a:t>
+              <a:t>•  East US 2 (US)</a:t>
             </a:r>
           </a:p>
           <a:p>
@@ -13735,13 +13760,13 @@
               </a:spcAft>
             </a:pPr>
             <a:r>
-              <a:rPr sz="1250" b="0" i="0">
-                <a:solidFill>
-                  <a:srgbClr val="1F2A37"/>
-                </a:solidFill>
-                <a:latin typeface="Calibri"/>
-              </a:rPr>
-              <a:t>•  East Asia, Australia Southeast (Asia Pacific)</a:t>
+              <a:rPr sz="1200" b="0" i="1">
+                <a:solidFill>
+                  <a:srgbClr val="5B6B7B"/>
+                </a:solidFill>
+                <a:latin typeface="Calibri"/>
+              </a:rPr>
+              <a:t>Japan East (Asia Pacific) — pending business confirmation, not yet selectable.</a:t>
             </a:r>
           </a:p>
         </p:txBody>
@@ -13990,7 +14015,7 @@
                 </a:solidFill>
                 <a:latin typeface="Calibri"/>
               </a:rPr>
-              <a:t>Middle East — Cross-Geo DR Extension</a:t>
+              <a:t>Middle East — DR Not Offered (Legal Pending)</a:t>
             </a:r>
           </a:p>
         </p:txBody>
@@ -14132,7 +14157,7 @@
         <p:spPr>
           <a:xfrm>
             <a:off x="548640" y="1645920"/>
-            <a:ext cx="11064240" cy="914400"/>
+            <a:ext cx="11064240" cy="1051560"/>
           </a:xfrm>
           <a:prstGeom prst="rect">
             <a:avLst/>
@@ -14160,7 +14185,7 @@
                 </a:solidFill>
                 <a:latin typeface="Calibri"/>
               </a:rPr>
-              <a:t>Middle East has only two Standard Capacity Regions, but a full deployment needs three (production, non-production, disaster recovery). The engine extends DR to Belgium Central in Europe — the only currently approved cross-geography DR path.</a:t>
+              <a:t>Middle East is a two-region geography (Saudi Arabia Central, UAE North) and is legal-owned. The current position is DR_NOT_OFFERED (DEC-001): data-sovereignty rules prevent cross-border DR, so no DR region is assigned. A cross-geo DR path to Switzerland North (Europe) is pre-configured but INACTIVE, pending legal clearance.</a:t>
             </a:r>
           </a:p>
         </p:txBody>
@@ -14332,7 +14357,7 @@
                 </a:solidFill>
                 <a:latin typeface="Calibri"/>
               </a:rPr>
-              <a:t>Higher-scoring of Saudi Arabia or UAE North</a:t>
+              <a:t>Higher-scoring of Saudi Arabia Central or UAE North</a:t>
             </a:r>
           </a:p>
         </p:txBody>
@@ -14462,7 +14487,7 @@
                 </a:solidFill>
                 <a:latin typeface="Calibri"/>
               </a:rPr>
-              <a:t>Non-production</a:t>
+              <a:t>Non-production (CVAL)</a:t>
             </a:r>
           </a:p>
         </p:txBody>
@@ -14524,7 +14549,7 @@
             <a:avLst/>
           </a:prstGeom>
           <a:solidFill>
-            <a:srgbClr val="1E8E3E"/>
+            <a:srgbClr val="C5221F"/>
           </a:solidFill>
           <a:ln>
             <a:noFill/>
@@ -14630,7 +14655,7 @@
             <a:r>
               <a:rPr sz="1500" b="1" i="0">
                 <a:solidFill>
-                  <a:srgbClr val="1E8E3E"/>
+                  <a:srgbClr val="C5221F"/>
                 </a:solidFill>
                 <a:latin typeface="Calibri"/>
               </a:rPr>
@@ -14676,7 +14701,7 @@
                 </a:solidFill>
                 <a:latin typeface="Calibri"/>
               </a:rPr>
-              <a:t>Belgium Central (Europe) — cross-geo</a:t>
+              <a:t>DR_NOT_OFFERED today (DEC-001) — no DR region assigned; Switzerland North path staged but inactive</a:t>
             </a:r>
           </a:p>
         </p:txBody>
@@ -14718,7 +14743,7 @@
                 </a:solidFill>
                 <a:latin typeface="Calibri"/>
               </a:rPr>
-              <a:t>Belgium Central must still pass capacity and quota checks; if it fails, the deployment is blocked with an alert — the engine never silently substitutes another region.</a:t>
+              <a:t>No DR is provisioned while DR_NOT_OFFERED is in force. Activating the staged Switzerland North cross-geo path is a legal/business decision (DEC-001); it would still have to pass capacity and quota checks, and the engine never silently substitutes another region.</a:t>
             </a:r>
           </a:p>
         </p:txBody>

</xml_diff>